<commit_message>
Slide 14: name the /review-pr skill explicitly
</commit_message>
<xml_diff>
--- a/slides/Colorado_Powracle_AlpineFrost.pptx
+++ b/slides/Colorado_Powracle_AlpineFrost.pptx
@@ -7322,7 +7322,7 @@
                 </a:solidFill>
                 <a:latin typeface="Calibri"/>
               </a:rPr>
-              <a:t>.github/pull_request_template.md  ·  the safety net</a:t>
+              <a:t>.github/pull_request_template.md  +  /review-pr skill</a:t>
             </a:r>
           </a:p>
         </p:txBody>
@@ -7357,8 +7357,8 @@
                 </a:solidFill>
                 <a:latin typeface="Calibri"/>
               </a:rPr>
-              <a:t>Every PR auto-loads a checklist: streamlit run cleanly · 2 canonical questions tested · no secrets staged · docs updated in the same PR · tools registered + prompt updated.
-/review-pr skill verifies each box against the diff and runtime — not the author's word.</a:t>
+              <a:t>Template auto-loads on every PR: streamlit run cleanly · 2 canonical questions tested · no secrets staged · docs updated in the same PR · tools registered + prompt updated.
+Custom Claude Code skill .claude/skills/review-pr/SKILL.md walks every checkbox against the actual diff and runtime (not just whether the box is ticked) and posts an audit comment.</a:t>
             </a:r>
           </a:p>
         </p:txBody>
@@ -7748,7 +7748,7 @@
                 </a:solidFill>
                 <a:latin typeface="Calibri"/>
               </a:rPr>
-              <a:t>/review-pr verifies vs. diff + runtime</a:t>
+              <a:t>/review-pr skill audits diff + runtime</a:t>
             </a:r>
           </a:p>
         </p:txBody>

</xml_diff>

<commit_message>
Slides 1 and 16: leave team names blank for teammates to fill
</commit_message>
<xml_diff>
--- a/slides/Colorado_Powracle_AlpineFrost.pptx
+++ b/slides/Colorado_Powracle_AlpineFrost.pptx
@@ -4724,7 +4724,7 @@
                 </a:solidFill>
                 <a:latin typeface="Calibri"/>
               </a:rPr>
-              <a:t>Chi-Hui Lin  ·  Drona  ·  Josef</a:t>
+              <a:t>[ team names — fill in ]</a:t>
             </a:r>
           </a:p>
         </p:txBody>
@@ -8647,7 +8647,7 @@
                 </a:solidFill>
                 <a:latin typeface="Calibri"/>
               </a:rPr>
-              <a:t>Chi-Hui Lin  ·  Drona  ·  Josef</a:t>
+              <a:t>[ team names — fill in ]</a:t>
             </a:r>
           </a:p>
         </p:txBody>

</xml_diff>

<commit_message>
Slides 1 and 16: add Chi-Hui Lin in first position, leave teammate slots
</commit_message>
<xml_diff>
--- a/slides/Colorado_Powracle_AlpineFrost.pptx
+++ b/slides/Colorado_Powracle_AlpineFrost.pptx
@@ -4724,7 +4724,7 @@
                 </a:solidFill>
                 <a:latin typeface="Calibri"/>
               </a:rPr>
-              <a:t>[ team names — fill in ]</a:t>
+              <a:t>Chi-Hui Lin  ·  [ teammate ]  ·  [ teammate ]</a:t>
             </a:r>
           </a:p>
         </p:txBody>
@@ -8647,7 +8647,7 @@
                 </a:solidFill>
                 <a:latin typeface="Calibri"/>
               </a:rPr>
-              <a:t>[ team names — fill in ]</a:t>
+              <a:t>Chi-Hui Lin  ·  [ teammate ]  ·  [ teammate ]</a:t>
             </a:r>
           </a:p>
         </p:txBody>

</xml_diff>

<commit_message>
Make GitHub URLs real hyperlinks on title and thank-you slides
</commit_message>
<xml_diff>
--- a/slides/Colorado_Powracle_AlpineFrost.pptx
+++ b/slides/Colorado_Powracle_AlpineFrost.pptx
@@ -4755,9 +4755,10 @@
             <a:r>
               <a:rPr sz="1200" b="0">
                 <a:solidFill>
-                  <a:srgbClr val="6B829A"/>
+                  <a:srgbClr val="7DC1E8"/>
                 </a:solidFill>
                 <a:latin typeface="Calibri"/>
+                <a:hlinkClick r:id="rId2"/>
               </a:rPr>
               <a:t>github.com/Ttopiac/colorado-powracle</a:t>
             </a:r>
@@ -8678,9 +8679,10 @@
             <a:r>
               <a:rPr sz="1300" b="0">
                 <a:solidFill>
-                  <a:srgbClr val="6B829A"/>
+                  <a:srgbClr val="7DC1E8"/>
                 </a:solidFill>
                 <a:latin typeface="Calibri"/>
+                <a:hlinkClick r:id="rId2"/>
               </a:rPr>
               <a:t>github.com/Ttopiac/colorado-powracle</a:t>
             </a:r>

</xml_diff>

<commit_message>
Update architecture diagrams: separate Skier and API Client entry points
- Simple and detailed Mermaid diagrams now show Skier → Streamlit UI
  and API Clients (eval harness, mobile, integrations) → FastAPI
- Slide 3: rewrite overview bullets to be concise, non-overlapping
  with later slides
</commit_message>
<xml_diff>
--- a/slides/Colorado_Powracle_AlpineFrost.pptx
+++ b/slides/Colorado_Powracle_AlpineFrost.pptx
@@ -9406,7 +9406,7 @@
                 </a:solidFill>
                 <a:latin typeface="Calibri"/>
               </a:rPr>
-              <a:t>ReAct agent · 6 tools · Streamlit UI + FastAPI · grounded data</a:t>
+              <a:t>Streamlit UI + FastAPI  ·  ReAct agent (Claude 3 Haiku)  ·  6 tools  ·  DuckDB + 4 live APIs  ·  PostgreSQL accounts</a:t>
             </a:r>
           </a:p>
         </p:txBody>
@@ -9443,8 +9443,8 @@
         </p:nvSpPr>
         <p:spPr>
           <a:xfrm>
-            <a:off x="548640" y="6126480"/>
-            <a:ext cx="11064240" cy="457200"/>
+            <a:off x="548640" y="3931920"/>
+            <a:ext cx="11064240" cy="2468880"/>
           </a:xfrm>
           <a:prstGeom prst="rect">
             <a:avLst/>
@@ -9457,15 +9457,63 @@
           </a:bodyPr>
           <a:lstStyle/>
           <a:p>
-            <a:pPr algn="l"/>
-            <a:r>
-              <a:rPr sz="1300" b="1">
+            <a:pPr algn="l">
+              <a:spcAft>
+                <a:spcPts val="800"/>
+              </a:spcAft>
+            </a:pPr>
+            <a:r>
+              <a:rPr sz="1800" b="1">
                 <a:solidFill>
                   <a:srgbClr val="6B829A"/>
                 </a:solidFill>
-                <a:latin typeface="Calibri"/>
-              </a:rPr>
-              <a:t>Streamlit UI and FastAPI both call the same chat_service.run_chat_turn — one agent, two front doors.</a:t>
+              </a:rPr>
+              <a:t>▸ Streamlit UI + FastAPI — two front doors, one shared agent</a:t>
+            </a:r>
+          </a:p>
+          <a:p>
+            <a:pPr algn="l">
+              <a:spcAft>
+                <a:spcPts val="800"/>
+              </a:spcAft>
+            </a:pPr>
+            <a:r>
+              <a:rPr sz="1800" b="1">
+                <a:solidFill>
+                  <a:srgbClr val="6B829A"/>
+                </a:solidFill>
+              </a:rPr>
+              <a:t>▸ 4 live APIs + 10-yr historical data in DuckDB — 6 tools total</a:t>
+            </a:r>
+          </a:p>
+          <a:p>
+            <a:pPr algn="l">
+              <a:spcAft>
+                <a:spcPts val="800"/>
+              </a:spcAft>
+            </a:pPr>
+            <a:r>
+              <a:rPr sz="1800" b="1">
+                <a:solidFill>
+                  <a:srgbClr val="6B829A"/>
+                </a:solidFill>
+              </a:rPr>
+              <a:t>▸ Deterministic fast path for simple factual questions</a:t>
+            </a:r>
+          </a:p>
+          <a:p>
+            <a:pPr algn="l">
+              <a:spcAft>
+                <a:spcPts val="800"/>
+              </a:spcAft>
+            </a:pPr>
+            <a:r>
+              <a:rPr sz="1800" b="1">
+                <a:solidFill>
+                  <a:srgbClr val="6B829A"/>
+                </a:solidFill>
+              </a:rPr>
+              <a:t>▸ PostgreSQL user accounts with guest-mode fallback</a:t>
             </a:r>
           </a:p>
         </p:txBody>

</xml_diff>